<commit_message>
Report and slides: single author, single-coder audit wording
Author line and title slide now name the sole author, Parth Mishra (National Institute of
Technology Warangal); the "EC418 team" placeholder is gone. The G3b placeholders describe the
amended design (random sample of 30, test-retest on 10, amendments A1-A2) instead of two blind
coders, and the limitations list the single coder. No AI tool, coder team or AI coder is mentioned
in report/, the slides or docs/P4_*.md (checked in the sources and in the built PDF/PPTX text).
Report still 6 pages; number check passes.
</commit_message>
<xml_diff>
--- a/report/EC418_slides.pptx
+++ b/report/EC418_slides.pptx
@@ -656,7 +656,7 @@
           <a:lstStyle/>
           <a:p>
             <a:r>
-              <a:t>The literature audit codes whether published CirCor papers use expert segmentation on test data; its result will be added after the two coders finish. The case study shows why headline numbers differ: a recent paper reports a balanced accuracy with test segments cut at expert S1 labels, which is not on the same scale as our AUROC.</a:t>
+              <a:t>The literature audit codes whether published CirCor papers use expert segmentation on test data; its result will be added once the coding of the random sample is complete. The case study shows why headline numbers differ: a recent paper reports a balanced accuracy with test segments cut at expert S1 labels, which is not on the same scale as our AUROC.</a:t>
             </a:r>
           </a:p>
         </p:txBody>
@@ -4628,7 +4628,7 @@
                   <a:srgbClr val="1F1F1E"/>
                 </a:solidFill>
               </a:rPr>
-              <a:t>• EC418 team — author names to be added</a:t>
+              <a:t>• Parth Mishra — National Institute of Technology Warangal</a:t>
             </a:r>
           </a:p>
         </p:txBody>
@@ -5027,7 +5027,7 @@
               </a:defRPr>
             </a:pPr>
             <a:r>
-              <a:t>G3b audit result — to be added after coding (sample of 30 records, two blind coders)</a:t>
+              <a:t>G3b audit result — to be added after coding (random sample of 30 records; test–retest on 10)</a:t>
             </a:r>
           </a:p>
         </p:txBody>

</xml_diff>

<commit_message>
Report and slides: G3b audit removed (amendment A3), audit listed as future work
Following amendment A3, the report has no literature-audit section, no placeholder and no
prevalence claim, and the single-coder limitation is gone. The Nogueira and Nie case studies stay
as neutral comparisons (slide 11 is now "Comparison with recent work"). The systematic audit of
test-time expert segmentation is listed as future work in the conclusion and on the conclusion
slide. The conditional "first evaluation on ZCHSound" sentence is removed, because its condition
(completed G3b full-text checks) can no longer be met; the factual note that ZCHSound was not among
Kutlu & Colak's targets stays. Number check passes; coding sheets untouched.
</commit_message>
<xml_diff>
--- a/report/EC418_slides.pptx
+++ b/report/EC418_slides.pptx
@@ -656,7 +656,7 @@
           <a:lstStyle/>
           <a:p>
             <a:r>
-              <a:t>The literature audit codes whether published CirCor papers use expert segmentation on test data; its result will be added once the coding of the random sample is complete. The case study shows why headline numbers differ: a recent paper reports a balanced accuracy with test segments cut at expert S1 labels, which is not on the same scale as our AUROC.</a:t>
+              <a:t>Recent papers report much higher numbers than ours, and these two show why they are not on the same scale. One reports a balanced accuracy at a single threshold with test segments cut at expert S1 labels; the other reports snippet accuracy on annotated periods. On the same balanced-accuracy scale our expert-label model is far lower.</a:t>
             </a:r>
           </a:p>
         </p:txBody>
@@ -796,7 +796,7 @@
           <a:lstStyle/>
           <a:p>
             <a:r>
-              <a:t>Timing matters, the transform does not, and a simple whole-signal model transfers to an independent CHD cohort with the expected physiological ordering. Future work is quality gating for noisy recordings, learned models under the same protocol, and a murmur-labelled external set.</a:t>
+              <a:t>Timing matters, the transform does not, and a simple whole-signal model transfers to an independent CHD cohort with the expected physiological ordering. Future work is quality gating for noisy recordings, learned models under the same protocol, a murmur-labelled external set, and a systematic audit of test-time expert segmentation in the literature.</a:t>
             </a:r>
           </a:p>
         </p:txBody>
@@ -4930,7 +4930,7 @@
               </a:defRPr>
             </a:pPr>
             <a:r>
-              <a:t>Literature audit and a 2026 comparison</a:t>
+              <a:t>Comparison with recent work</a:t>
             </a:r>
           </a:p>
         </p:txBody>
@@ -4980,68 +4980,14 @@
       </p:sp>
       <p:sp>
         <p:nvSpPr>
-          <p:cNvPr id="4" name="Rounded Rectangle 3"/>
-          <p:cNvSpPr/>
+          <p:cNvPr id="4" name="TextBox 3"/>
+          <p:cNvSpPr txBox="1"/>
           <p:nvPr/>
         </p:nvSpPr>
         <p:spPr>
           <a:xfrm>
-            <a:off x="548640" y="1463040"/>
-            <a:ext cx="11064240" cy="914400"/>
-          </a:xfrm>
-          <a:prstGeom prst="roundRect">
-            <a:avLst/>
-          </a:prstGeom>
-          <a:solidFill>
-            <a:srgbClr val="EDEDE8"/>
-          </a:solidFill>
-          <a:ln>
-            <a:solidFill>
-              <a:srgbClr val="6B6A64"/>
-            </a:solidFill>
-          </a:ln>
-        </p:spPr>
-        <p:style>
-          <a:lnRef idx="1">
-            <a:schemeClr val="accent1"/>
-          </a:lnRef>
-          <a:fillRef idx="3">
-            <a:schemeClr val="accent1"/>
-          </a:fillRef>
-          <a:effectRef idx="2">
-            <a:schemeClr val="accent1"/>
-          </a:effectRef>
-          <a:fontRef idx="minor">
-            <a:schemeClr val="lt1"/>
-          </a:fontRef>
-        </p:style>
-        <p:txBody>
-          <a:bodyPr rtlCol="0" anchor="ctr" wrap="square"/>
-          <a:lstStyle/>
-          <a:p>
-            <a:pPr algn="ctr">
-              <a:defRPr sz="2000">
-                <a:solidFill>
-                  <a:srgbClr val="6B6A64"/>
-                </a:solidFill>
-              </a:defRPr>
-            </a:pPr>
-            <a:r>
-              <a:t>G3b audit result — to be added after coding (random sample of 30 records; test–retest on 10)</a:t>
-            </a:r>
-          </a:p>
-        </p:txBody>
-      </p:sp>
-      <p:sp>
-        <p:nvSpPr>
-          <p:cNvPr id="5" name="TextBox 4"/>
-          <p:cNvSpPr txBox="1"/>
-          <p:nvPr/>
-        </p:nvSpPr>
-        <p:spPr>
-          <a:xfrm>
-            <a:off x="548640" y="2651760"/>
-            <a:ext cx="11064240" cy="3931920"/>
+            <a:off x="548640" y="1554480"/>
+            <a:ext cx="11064240" cy="4754880"/>
           </a:xfrm>
           <a:prstGeom prst="rect">
             <a:avLst/>
@@ -5060,7 +5006,7 @@
               </a:spcAft>
             </a:pPr>
             <a:r>
-              <a:rPr sz="2000" b="1">
+              <a:rPr sz="2200" b="1">
                 <a:solidFill>
                   <a:srgbClr val="1F1F1E"/>
                 </a:solidFill>
@@ -5068,7 +5014,7 @@
               <a:t>• Nogueira et al. 2026: </a:t>
             </a:r>
             <a:r>
-              <a:rPr sz="2000" b="0">
+              <a:rPr sz="2200" b="0">
                 <a:solidFill>
                   <a:srgbClr val="1F1F1E"/>
                 </a:solidFill>
@@ -5083,7 +5029,7 @@
               </a:spcAft>
             </a:pPr>
             <a:r>
-              <a:rPr sz="2000" b="0">
+              <a:rPr sz="2200" b="0">
                 <a:solidFill>
                   <a:srgbClr val="1F1F1E"/>
                 </a:solidFill>
@@ -5098,7 +5044,7 @@
               </a:spcAft>
             </a:pPr>
             <a:r>
-              <a:rPr sz="2000" b="0">
+              <a:rPr sz="2200" b="0">
                 <a:solidFill>
                   <a:srgbClr val="1F1F1E"/>
                 </a:solidFill>
@@ -5113,7 +5059,7 @@
               </a:spcAft>
             </a:pPr>
             <a:r>
-              <a:rPr sz="2000" b="0">
+              <a:rPr sz="2200" b="0">
                 <a:solidFill>
                   <a:srgbClr val="1F1F1E"/>
                 </a:solidFill>
@@ -5128,7 +5074,7 @@
               </a:spcAft>
             </a:pPr>
             <a:r>
-              <a:rPr sz="2000" b="0">
+              <a:rPr sz="2200" b="0">
                 <a:solidFill>
                   <a:srgbClr val="1F1F1E"/>
                 </a:solidFill>
@@ -5585,6 +5531,21 @@
                 </a:solidFill>
               </a:rPr>
               <a:t>• Next: quality gating, learned models under the same protocol, murmur-labelled external data</a:t>
+            </a:r>
+          </a:p>
+          <a:p>
+            <a:pPr>
+              <a:spcAft>
+                <a:spcPts val="800"/>
+              </a:spcAft>
+            </a:pPr>
+            <a:r>
+              <a:rPr sz="2400" b="0">
+                <a:solidFill>
+                  <a:srgbClr val="1F1F1E"/>
+                </a:solidFill>
+              </a:rPr>
+              <a:t>• Future: a systematic audit of test-time expert segmentation in published CirCor work</a:t>
             </a:r>
           </a:p>
         </p:txBody>

</xml_diff>

<commit_message>
docs: prepare final EC418 report and presentation
submission/ holds the deliverables: a 15-page research report (LaTeX source in report_src/,
built with tectonic) covering the required sections from clinical problem and literature
review to wavelet mathematics, protocol, results, ablations, failed hypotheses, automatic
segmentation, shortcut learning, external test, limitations, reproducibility and an
AI-assistance statement; a 17-slide presentation (scripts/p5_submission_slides.py) with
speaker notes; and a checklist with real statuses. All results enter through the numbers
registry; 2024-2026 literature values were added to case_study_numbers.csv with their quoted
source and printed as reported. The number check now also covers the submission report and
deck; both were rendered and inspected. Team metadata are marked placeholders.
The draft deck in report/ takes the final title and the corrected H9a wording.
docs/REPOSITORY_AUDIT.md records the audit table with statuses.
</commit_message>
<xml_diff>
--- a/report/EC418_slides.pptx
+++ b/report/EC418_slides.pptx
@@ -1496,7 +1496,7 @@
           <a:lstStyle/>
           <a:p>
             <a:r>
-              <a:t>With a learned span detector the automatic pipeline matches expert labels. But its span fraction is itself predictive, so we built a shortcut-free version, E4q. E4q keeps the AUROC and beats random windows, yet its margin over a whole-signal STFT baseline with the same span information has a confidence interval that touches zero, so that advantage is not established.</a:t>
+              <a:t>With a learned span detector the automatic pipeline comes within the pre-registered margin of expert labels on the point estimate, although the confidence interval is too wide to establish non-inferiority. Its span fraction is also predictive, so we built a shortcut-free version, E4q. E4q keeps the AUROC and beats random windows, yet its margin over a whole-signal STFT baseline with the same span information has a confidence interval that touches zero, so that advantage is not established.</a:t>
             </a:r>
           </a:p>
         </p:txBody>
@@ -4532,7 +4532,7 @@
               </a:defRPr>
             </a:pPr>
             <a:r>
-              <a:t>Timing, Not Transform</a:t>
+              <a:t>Physiology-Aligned Multiresolution Analysis</a:t>
             </a:r>
           </a:p>
         </p:txBody>
@@ -4613,7 +4613,7 @@
                   <a:srgbClr val="1F1F1E"/>
                 </a:solidFill>
               </a:rPr>
-              <a:t>• Shortcut-controlled and externally validated murmur detection on CirCor</a:t>
+              <a:t>• for Patient-Independent Heart-Murmur Detection: a comparative study of wavelet and Fourier features</a:t>
             </a:r>
           </a:p>
           <a:p>
@@ -8779,7 +8779,7 @@
                   <a:srgbClr val="1F1F1E"/>
                 </a:solidFill>
               </a:rPr>
-              <a:t>−0.007 to −0.005, non-inferior</a:t>
+              <a:t>−0.007 to −0.005; rule met, non-inferiority not established</a:t>
             </a:r>
           </a:p>
           <a:p>

</xml_diff>